<commit_message>
docs: 📄 update diagram files in README documentation
</commit_message>
<xml_diff>
--- a/docs/README/diagram.pptx
+++ b/docs/README/diagram.pptx
@@ -107,6 +107,22 @@
       </a:defRPr>
     </a:lvl9pPr>
   </p:defaultTextStyle>
+  <p:extLst>
+    <p:ext uri="{EFAFB233-063F-42B5-8137-9DF3F51BA10A}">
+      <p15:sldGuideLst xmlns:p15="http://schemas.microsoft.com/office/powerpoint/2012/main">
+        <p15:guide id="1" orient="horz" pos="2160">
+          <p15:clr>
+            <a:srgbClr val="A4A3A4"/>
+          </p15:clr>
+        </p15:guide>
+        <p15:guide id="2" pos="2880">
+          <p15:clr>
+            <a:srgbClr val="A4A3A4"/>
+          </p15:clr>
+        </p15:guide>
+      </p15:sldGuideLst>
+    </p:ext>
+  </p:extLst>
 </p:presentation>
 </file>
 
@@ -292,9 +308,9 @@
             <a:fld id="{6C456EFC-280F-4226-A86B-795CA61BECAE}" type="datetimeFigureOut">
               <a:rPr lang="en-US" smtClean="0"/>
               <a:pPr/>
-              <a:t>7/29/2024</a:t>
+              <a:t>4/6/2026</a:t>
             </a:fld>
-            <a:endParaRPr lang="en-US"/>
+            <a:endParaRPr lang="en-US" dirty="0"/>
           </a:p>
         </p:txBody>
       </p:sp>
@@ -313,7 +329,7 @@
           <a:bodyPr/>
           <a:lstStyle/>
           <a:p>
-            <a:endParaRPr lang="en-US"/>
+            <a:endParaRPr lang="en-US" dirty="0"/>
           </a:p>
         </p:txBody>
       </p:sp>
@@ -335,9 +351,9 @@
             <a:fld id="{055EF302-1BCD-4D16-835D-232A915B8A2F}" type="slidenum">
               <a:rPr lang="en-US" smtClean="0"/>
               <a:pPr/>
-              <a:t>‹N°›</a:t>
+              <a:t>‹#›</a:t>
             </a:fld>
-            <a:endParaRPr lang="en-US"/>
+            <a:endParaRPr lang="en-US" dirty="0"/>
           </a:p>
         </p:txBody>
       </p:sp>
@@ -459,9 +475,9 @@
             <a:fld id="{6C456EFC-280F-4226-A86B-795CA61BECAE}" type="datetimeFigureOut">
               <a:rPr lang="en-US" smtClean="0"/>
               <a:pPr/>
-              <a:t>7/29/2024</a:t>
+              <a:t>4/6/2026</a:t>
             </a:fld>
-            <a:endParaRPr lang="en-US"/>
+            <a:endParaRPr lang="en-US" dirty="0"/>
           </a:p>
         </p:txBody>
       </p:sp>
@@ -480,7 +496,7 @@
           <a:bodyPr/>
           <a:lstStyle/>
           <a:p>
-            <a:endParaRPr lang="en-US"/>
+            <a:endParaRPr lang="en-US" dirty="0"/>
           </a:p>
         </p:txBody>
       </p:sp>
@@ -502,9 +518,9 @@
             <a:fld id="{055EF302-1BCD-4D16-835D-232A915B8A2F}" type="slidenum">
               <a:rPr lang="en-US" smtClean="0"/>
               <a:pPr/>
-              <a:t>‹N°›</a:t>
+              <a:t>‹#›</a:t>
             </a:fld>
-            <a:endParaRPr lang="en-US"/>
+            <a:endParaRPr lang="en-US" dirty="0"/>
           </a:p>
         </p:txBody>
       </p:sp>
@@ -636,9 +652,9 @@
             <a:fld id="{6C456EFC-280F-4226-A86B-795CA61BECAE}" type="datetimeFigureOut">
               <a:rPr lang="en-US" smtClean="0"/>
               <a:pPr/>
-              <a:t>7/29/2024</a:t>
+              <a:t>4/6/2026</a:t>
             </a:fld>
-            <a:endParaRPr lang="en-US"/>
+            <a:endParaRPr lang="en-US" dirty="0"/>
           </a:p>
         </p:txBody>
       </p:sp>
@@ -657,7 +673,7 @@
           <a:bodyPr/>
           <a:lstStyle/>
           <a:p>
-            <a:endParaRPr lang="en-US"/>
+            <a:endParaRPr lang="en-US" dirty="0"/>
           </a:p>
         </p:txBody>
       </p:sp>
@@ -679,9 +695,9 @@
             <a:fld id="{055EF302-1BCD-4D16-835D-232A915B8A2F}" type="slidenum">
               <a:rPr lang="en-US" smtClean="0"/>
               <a:pPr/>
-              <a:t>‹N°›</a:t>
+              <a:t>‹#›</a:t>
             </a:fld>
-            <a:endParaRPr lang="en-US"/>
+            <a:endParaRPr lang="en-US" dirty="0"/>
           </a:p>
         </p:txBody>
       </p:sp>
@@ -803,9 +819,9 @@
             <a:fld id="{6C456EFC-280F-4226-A86B-795CA61BECAE}" type="datetimeFigureOut">
               <a:rPr lang="en-US" smtClean="0"/>
               <a:pPr/>
-              <a:t>7/29/2024</a:t>
+              <a:t>4/6/2026</a:t>
             </a:fld>
-            <a:endParaRPr lang="en-US"/>
+            <a:endParaRPr lang="en-US" dirty="0"/>
           </a:p>
         </p:txBody>
       </p:sp>
@@ -824,7 +840,7 @@
           <a:bodyPr/>
           <a:lstStyle/>
           <a:p>
-            <a:endParaRPr lang="en-US"/>
+            <a:endParaRPr lang="en-US" dirty="0"/>
           </a:p>
         </p:txBody>
       </p:sp>
@@ -846,9 +862,9 @@
             <a:fld id="{055EF302-1BCD-4D16-835D-232A915B8A2F}" type="slidenum">
               <a:rPr lang="en-US" smtClean="0"/>
               <a:pPr/>
-              <a:t>‹N°›</a:t>
+              <a:t>‹#›</a:t>
             </a:fld>
-            <a:endParaRPr lang="en-US"/>
+            <a:endParaRPr lang="en-US" dirty="0"/>
           </a:p>
         </p:txBody>
       </p:sp>
@@ -1046,9 +1062,9 @@
             <a:fld id="{6C456EFC-280F-4226-A86B-795CA61BECAE}" type="datetimeFigureOut">
               <a:rPr lang="en-US" smtClean="0"/>
               <a:pPr/>
-              <a:t>7/29/2024</a:t>
+              <a:t>4/6/2026</a:t>
             </a:fld>
-            <a:endParaRPr lang="en-US"/>
+            <a:endParaRPr lang="en-US" dirty="0"/>
           </a:p>
         </p:txBody>
       </p:sp>
@@ -1067,7 +1083,7 @@
           <a:bodyPr/>
           <a:lstStyle/>
           <a:p>
-            <a:endParaRPr lang="en-US"/>
+            <a:endParaRPr lang="en-US" dirty="0"/>
           </a:p>
         </p:txBody>
       </p:sp>
@@ -1089,9 +1105,9 @@
             <a:fld id="{055EF302-1BCD-4D16-835D-232A915B8A2F}" type="slidenum">
               <a:rPr lang="en-US" smtClean="0"/>
               <a:pPr/>
-              <a:t>‹N°›</a:t>
+              <a:t>‹#›</a:t>
             </a:fld>
-            <a:endParaRPr lang="en-US"/>
+            <a:endParaRPr lang="en-US" dirty="0"/>
           </a:p>
         </p:txBody>
       </p:sp>
@@ -1331,9 +1347,9 @@
             <a:fld id="{6C456EFC-280F-4226-A86B-795CA61BECAE}" type="datetimeFigureOut">
               <a:rPr lang="en-US" smtClean="0"/>
               <a:pPr/>
-              <a:t>7/29/2024</a:t>
+              <a:t>4/6/2026</a:t>
             </a:fld>
-            <a:endParaRPr lang="en-US"/>
+            <a:endParaRPr lang="en-US" dirty="0"/>
           </a:p>
         </p:txBody>
       </p:sp>
@@ -1352,7 +1368,7 @@
           <a:bodyPr/>
           <a:lstStyle/>
           <a:p>
-            <a:endParaRPr lang="en-US"/>
+            <a:endParaRPr lang="en-US" dirty="0"/>
           </a:p>
         </p:txBody>
       </p:sp>
@@ -1374,9 +1390,9 @@
             <a:fld id="{055EF302-1BCD-4D16-835D-232A915B8A2F}" type="slidenum">
               <a:rPr lang="en-US" smtClean="0"/>
               <a:pPr/>
-              <a:t>‹N°›</a:t>
+              <a:t>‹#›</a:t>
             </a:fld>
-            <a:endParaRPr lang="en-US"/>
+            <a:endParaRPr lang="en-US" dirty="0"/>
           </a:p>
         </p:txBody>
       </p:sp>
@@ -1750,9 +1766,9 @@
             <a:fld id="{6C456EFC-280F-4226-A86B-795CA61BECAE}" type="datetimeFigureOut">
               <a:rPr lang="en-US" smtClean="0"/>
               <a:pPr/>
-              <a:t>7/29/2024</a:t>
+              <a:t>4/6/2026</a:t>
             </a:fld>
-            <a:endParaRPr lang="en-US"/>
+            <a:endParaRPr lang="en-US" dirty="0"/>
           </a:p>
         </p:txBody>
       </p:sp>
@@ -1771,7 +1787,7 @@
           <a:bodyPr/>
           <a:lstStyle/>
           <a:p>
-            <a:endParaRPr lang="en-US"/>
+            <a:endParaRPr lang="en-US" dirty="0"/>
           </a:p>
         </p:txBody>
       </p:sp>
@@ -1793,9 +1809,9 @@
             <a:fld id="{055EF302-1BCD-4D16-835D-232A915B8A2F}" type="slidenum">
               <a:rPr lang="en-US" smtClean="0"/>
               <a:pPr/>
-              <a:t>‹N°›</a:t>
+              <a:t>‹#›</a:t>
             </a:fld>
-            <a:endParaRPr lang="en-US"/>
+            <a:endParaRPr lang="en-US" dirty="0"/>
           </a:p>
         </p:txBody>
       </p:sp>
@@ -1865,9 +1881,9 @@
             <a:fld id="{6C456EFC-280F-4226-A86B-795CA61BECAE}" type="datetimeFigureOut">
               <a:rPr lang="en-US" smtClean="0"/>
               <a:pPr/>
-              <a:t>7/29/2024</a:t>
+              <a:t>4/6/2026</a:t>
             </a:fld>
-            <a:endParaRPr lang="en-US"/>
+            <a:endParaRPr lang="en-US" dirty="0"/>
           </a:p>
         </p:txBody>
       </p:sp>
@@ -1886,7 +1902,7 @@
           <a:bodyPr/>
           <a:lstStyle/>
           <a:p>
-            <a:endParaRPr lang="en-US"/>
+            <a:endParaRPr lang="en-US" dirty="0"/>
           </a:p>
         </p:txBody>
       </p:sp>
@@ -1908,9 +1924,9 @@
             <a:fld id="{055EF302-1BCD-4D16-835D-232A915B8A2F}" type="slidenum">
               <a:rPr lang="en-US" smtClean="0"/>
               <a:pPr/>
-              <a:t>‹N°›</a:t>
+              <a:t>‹#›</a:t>
             </a:fld>
-            <a:endParaRPr lang="en-US"/>
+            <a:endParaRPr lang="en-US" dirty="0"/>
           </a:p>
         </p:txBody>
       </p:sp>
@@ -1957,9 +1973,9 @@
             <a:fld id="{6C456EFC-280F-4226-A86B-795CA61BECAE}" type="datetimeFigureOut">
               <a:rPr lang="en-US" smtClean="0"/>
               <a:pPr/>
-              <a:t>7/29/2024</a:t>
+              <a:t>4/6/2026</a:t>
             </a:fld>
-            <a:endParaRPr lang="en-US"/>
+            <a:endParaRPr lang="en-US" dirty="0"/>
           </a:p>
         </p:txBody>
       </p:sp>
@@ -1978,7 +1994,7 @@
           <a:bodyPr/>
           <a:lstStyle/>
           <a:p>
-            <a:endParaRPr lang="en-US"/>
+            <a:endParaRPr lang="en-US" dirty="0"/>
           </a:p>
         </p:txBody>
       </p:sp>
@@ -2000,9 +2016,9 @@
             <a:fld id="{055EF302-1BCD-4D16-835D-232A915B8A2F}" type="slidenum">
               <a:rPr lang="en-US" smtClean="0"/>
               <a:pPr/>
-              <a:t>‹N°›</a:t>
+              <a:t>‹#›</a:t>
             </a:fld>
-            <a:endParaRPr lang="en-US"/>
+            <a:endParaRPr lang="en-US" dirty="0"/>
           </a:p>
         </p:txBody>
       </p:sp>
@@ -2231,9 +2247,9 @@
             <a:fld id="{6C456EFC-280F-4226-A86B-795CA61BECAE}" type="datetimeFigureOut">
               <a:rPr lang="en-US" smtClean="0"/>
               <a:pPr/>
-              <a:t>7/29/2024</a:t>
+              <a:t>4/6/2026</a:t>
             </a:fld>
-            <a:endParaRPr lang="en-US"/>
+            <a:endParaRPr lang="en-US" dirty="0"/>
           </a:p>
         </p:txBody>
       </p:sp>
@@ -2252,7 +2268,7 @@
           <a:bodyPr/>
           <a:lstStyle/>
           <a:p>
-            <a:endParaRPr lang="en-US"/>
+            <a:endParaRPr lang="en-US" dirty="0"/>
           </a:p>
         </p:txBody>
       </p:sp>
@@ -2274,9 +2290,9 @@
             <a:fld id="{055EF302-1BCD-4D16-835D-232A915B8A2F}" type="slidenum">
               <a:rPr lang="en-US" smtClean="0"/>
               <a:pPr/>
-              <a:t>‹N°›</a:t>
+              <a:t>‹#›</a:t>
             </a:fld>
-            <a:endParaRPr lang="en-US"/>
+            <a:endParaRPr lang="en-US" dirty="0"/>
           </a:p>
         </p:txBody>
       </p:sp>
@@ -2394,7 +2410,7 @@
             </a:lvl9pPr>
           </a:lstStyle>
           <a:p>
-            <a:endParaRPr lang="en-US"/>
+            <a:endParaRPr lang="en-US" dirty="0"/>
           </a:p>
         </p:txBody>
       </p:sp>
@@ -2481,9 +2497,9 @@
             <a:fld id="{6C456EFC-280F-4226-A86B-795CA61BECAE}" type="datetimeFigureOut">
               <a:rPr lang="en-US" smtClean="0"/>
               <a:pPr/>
-              <a:t>7/29/2024</a:t>
+              <a:t>4/6/2026</a:t>
             </a:fld>
-            <a:endParaRPr lang="en-US"/>
+            <a:endParaRPr lang="en-US" dirty="0"/>
           </a:p>
         </p:txBody>
       </p:sp>
@@ -2502,7 +2518,7 @@
           <a:bodyPr/>
           <a:lstStyle/>
           <a:p>
-            <a:endParaRPr lang="en-US"/>
+            <a:endParaRPr lang="en-US" dirty="0"/>
           </a:p>
         </p:txBody>
       </p:sp>
@@ -2524,9 +2540,9 @@
             <a:fld id="{055EF302-1BCD-4D16-835D-232A915B8A2F}" type="slidenum">
               <a:rPr lang="en-US" smtClean="0"/>
               <a:pPr/>
-              <a:t>‹N°›</a:t>
+              <a:t>‹#›</a:t>
             </a:fld>
-            <a:endParaRPr lang="en-US"/>
+            <a:endParaRPr lang="en-US" dirty="0"/>
           </a:p>
         </p:txBody>
       </p:sp>
@@ -2691,9 +2707,9 @@
             <a:fld id="{6C456EFC-280F-4226-A86B-795CA61BECAE}" type="datetimeFigureOut">
               <a:rPr lang="en-US" smtClean="0"/>
               <a:pPr/>
-              <a:t>7/29/2024</a:t>
+              <a:t>4/6/2026</a:t>
             </a:fld>
-            <a:endParaRPr lang="en-US"/>
+            <a:endParaRPr lang="en-US" dirty="0"/>
           </a:p>
         </p:txBody>
       </p:sp>
@@ -2730,7 +2746,7 @@
             </a:lvl1pPr>
           </a:lstStyle>
           <a:p>
-            <a:endParaRPr lang="en-US"/>
+            <a:endParaRPr lang="en-US" dirty="0"/>
           </a:p>
         </p:txBody>
       </p:sp>
@@ -2770,9 +2786,9 @@
             <a:fld id="{055EF302-1BCD-4D16-835D-232A915B8A2F}" type="slidenum">
               <a:rPr lang="en-US" smtClean="0"/>
               <a:pPr/>
-              <a:t>‹N°›</a:t>
+              <a:t>‹#›</a:t>
             </a:fld>
-            <a:endParaRPr lang="en-US"/>
+            <a:endParaRPr lang="en-US" dirty="0"/>
           </a:p>
         </p:txBody>
       </p:sp>
@@ -4075,7 +4091,7 @@
           <a:lstStyle/>
           <a:p>
             <a:pPr algn="ctr"/>
-            <a:endParaRPr lang="en-US"/>
+            <a:endParaRPr lang="en-US" dirty="0"/>
           </a:p>
         </p:txBody>
       </p:sp>
@@ -4113,7 +4129,7 @@
           <a:lstStyle/>
           <a:p>
             <a:pPr algn="ctr"/>
-            <a:endParaRPr lang="en-US"/>
+            <a:endParaRPr lang="en-US" dirty="0"/>
           </a:p>
         </p:txBody>
       </p:sp>
@@ -4247,7 +4263,7 @@
           <a:lstStyle/>
           <a:p>
             <a:pPr algn="ctr"/>
-            <a:endParaRPr lang="en-US"/>
+            <a:endParaRPr lang="en-US" dirty="0"/>
           </a:p>
         </p:txBody>
       </p:sp>
@@ -4340,7 +4356,7 @@
           <a:lstStyle/>
           <a:p>
             <a:pPr algn="ctr"/>
-            <a:endParaRPr lang="en-US"/>
+            <a:endParaRPr lang="en-US" dirty="0"/>
           </a:p>
         </p:txBody>
       </p:sp>
@@ -4378,7 +4394,7 @@
           <a:lstStyle/>
           <a:p>
             <a:pPr algn="ctr"/>
-            <a:endParaRPr lang="en-US"/>
+            <a:endParaRPr lang="en-US" dirty="0"/>
           </a:p>
         </p:txBody>
       </p:sp>
@@ -4416,7 +4432,7 @@
           <a:lstStyle/>
           <a:p>
             <a:pPr algn="ctr"/>
-            <a:endParaRPr lang="en-US"/>
+            <a:endParaRPr lang="en-US" dirty="0"/>
           </a:p>
         </p:txBody>
       </p:sp>
@@ -4454,7 +4470,7 @@
           <a:lstStyle/>
           <a:p>
             <a:pPr algn="ctr"/>
-            <a:endParaRPr lang="en-US"/>
+            <a:endParaRPr lang="en-US" dirty="0"/>
           </a:p>
         </p:txBody>
       </p:sp>
@@ -4492,7 +4508,7 @@
           <a:lstStyle/>
           <a:p>
             <a:pPr algn="ctr"/>
-            <a:endParaRPr lang="en-US"/>
+            <a:endParaRPr lang="en-US" dirty="0"/>
           </a:p>
         </p:txBody>
       </p:sp>
@@ -4530,7 +4546,7 @@
           <a:lstStyle/>
           <a:p>
             <a:pPr algn="ctr"/>
-            <a:endParaRPr lang="en-US"/>
+            <a:endParaRPr lang="en-US" dirty="0"/>
           </a:p>
         </p:txBody>
       </p:sp>
@@ -4568,7 +4584,7 @@
           <a:lstStyle/>
           <a:p>
             <a:pPr algn="ctr"/>
-            <a:endParaRPr lang="en-US"/>
+            <a:endParaRPr lang="en-US" dirty="0"/>
           </a:p>
         </p:txBody>
       </p:sp>
@@ -4639,7 +4655,7 @@
           <a:lstStyle/>
           <a:p>
             <a:pPr algn="ctr"/>
-            <a:endParaRPr lang="en-US"/>
+            <a:endParaRPr lang="en-US" dirty="0"/>
           </a:p>
         </p:txBody>
       </p:sp>
@@ -5150,27 +5166,7 @@
           <a:p>
             <a:r>
               <a:rPr lang="en-US" b="1" dirty="0" smtClean="0"/>
-              <a:t>social-</a:t>
-            </a:r>
-            <a:r>
-              <a:rPr lang="en-US" b="1" dirty="0" err="1" smtClean="0"/>
-              <a:t>bot</a:t>
-            </a:r>
-            <a:r>
-              <a:rPr lang="en-US" b="1" dirty="0" smtClean="0"/>
-              <a:t>-@</a:t>
-            </a:r>
-            <a:r>
-              <a:rPr lang="en-US" b="1" dirty="0" err="1" smtClean="0"/>
-              <a:t>frimoussethecat</a:t>
-            </a:r>
-            <a:r>
-              <a:rPr lang="en-US" b="1" dirty="0" smtClean="0"/>
-              <a:t>-post-</a:t>
-            </a:r>
-            <a:r>
-              <a:rPr lang="en-US" b="1" dirty="0" err="1" smtClean="0"/>
-              <a:t>pics.py</a:t>
+              <a:t>social-bot-@frimoussethecat-post-pics.py</a:t>
             </a:r>
             <a:endParaRPr lang="en-US" b="1" dirty="0"/>
           </a:p>
@@ -5382,7 +5378,7 @@
           <a:lstStyle/>
           <a:p>
             <a:pPr algn="ctr"/>
-            <a:endParaRPr lang="en-US"/>
+            <a:endParaRPr lang="en-US" dirty="0"/>
           </a:p>
         </p:txBody>
       </p:sp>
@@ -5420,7 +5416,7 @@
           <a:lstStyle/>
           <a:p>
             <a:pPr algn="ctr"/>
-            <a:endParaRPr lang="en-US"/>
+            <a:endParaRPr lang="en-US" dirty="0"/>
           </a:p>
         </p:txBody>
       </p:sp>
@@ -5458,7 +5454,7 @@
           <a:lstStyle/>
           <a:p>
             <a:pPr algn="ctr"/>
-            <a:endParaRPr lang="en-US"/>
+            <a:endParaRPr lang="en-US" dirty="0"/>
           </a:p>
         </p:txBody>
       </p:sp>
@@ -5545,7 +5541,7 @@
           <a:lstStyle/>
           <a:p>
             <a:pPr algn="ctr"/>
-            <a:endParaRPr lang="en-US"/>
+            <a:endParaRPr lang="en-US" dirty="0"/>
           </a:p>
         </p:txBody>
       </p:sp>
@@ -5583,7 +5579,7 @@
           <a:lstStyle/>
           <a:p>
             <a:pPr algn="ctr"/>
-            <a:endParaRPr lang="en-US"/>
+            <a:endParaRPr lang="en-US" dirty="0"/>
           </a:p>
         </p:txBody>
       </p:sp>
@@ -5621,7 +5617,7 @@
           <a:lstStyle/>
           <a:p>
             <a:pPr algn="ctr"/>
-            <a:endParaRPr lang="en-US"/>
+            <a:endParaRPr lang="en-US" dirty="0"/>
           </a:p>
         </p:txBody>
       </p:sp>
@@ -5807,7 +5803,7 @@
           <a:lstStyle/>
           <a:p>
             <a:pPr algn="ctr"/>
-            <a:endParaRPr lang="en-US"/>
+            <a:endParaRPr lang="en-US" dirty="0"/>
           </a:p>
         </p:txBody>
       </p:sp>
@@ -6549,27 +6545,7 @@
           <a:p>
             <a:r>
               <a:rPr lang="en-US" b="1" dirty="0" smtClean="0"/>
-              <a:t>social-</a:t>
-            </a:r>
-            <a:r>
-              <a:rPr lang="en-US" b="1" dirty="0" err="1" smtClean="0"/>
-              <a:t>bot</a:t>
-            </a:r>
-            <a:r>
-              <a:rPr lang="en-US" b="1" dirty="0" smtClean="0"/>
-              <a:t>-@</a:t>
-            </a:r>
-            <a:r>
-              <a:rPr lang="en-US" b="1" dirty="0" err="1" smtClean="0"/>
-              <a:t>frimoussethecat</a:t>
-            </a:r>
-            <a:r>
-              <a:rPr lang="en-US" b="1" dirty="0" smtClean="0"/>
-              <a:t>-post-</a:t>
-            </a:r>
-            <a:r>
-              <a:rPr lang="en-US" b="1" dirty="0" err="1" smtClean="0"/>
-              <a:t>vids.py</a:t>
+              <a:t>social-bot-@frimoussethecat-post-vids.py</a:t>
             </a:r>
             <a:endParaRPr lang="en-US" b="1" dirty="0"/>
           </a:p>
@@ -6883,7 +6859,7 @@
           <a:lstStyle/>
           <a:p>
             <a:pPr algn="ctr"/>
-            <a:endParaRPr lang="en-US"/>
+            <a:endParaRPr lang="en-US" dirty="0"/>
           </a:p>
         </p:txBody>
       </p:sp>
@@ -6921,7 +6897,7 @@
           <a:lstStyle/>
           <a:p>
             <a:pPr algn="ctr"/>
-            <a:endParaRPr lang="en-US"/>
+            <a:endParaRPr lang="en-US" dirty="0"/>
           </a:p>
         </p:txBody>
       </p:sp>
@@ -6959,7 +6935,7 @@
           <a:lstStyle/>
           <a:p>
             <a:pPr algn="ctr"/>
-            <a:endParaRPr lang="en-US"/>
+            <a:endParaRPr lang="en-US" dirty="0"/>
           </a:p>
         </p:txBody>
       </p:sp>
@@ -7000,7 +6976,7 @@
           <a:lstStyle/>
           <a:p>
             <a:pPr algn="ctr"/>
-            <a:endParaRPr lang="en-US"/>
+            <a:endParaRPr lang="en-US" dirty="0"/>
           </a:p>
         </p:txBody>
       </p:sp>
@@ -7041,7 +7017,7 @@
           <a:lstStyle/>
           <a:p>
             <a:pPr algn="ctr"/>
-            <a:endParaRPr lang="en-US"/>
+            <a:endParaRPr lang="en-US" dirty="0"/>
           </a:p>
         </p:txBody>
       </p:sp>
@@ -7567,27 +7543,7 @@
           <a:p>
             <a:r>
               <a:rPr lang="en-US" b="1" dirty="0" smtClean="0"/>
-              <a:t>social-</a:t>
-            </a:r>
-            <a:r>
-              <a:rPr lang="en-US" b="1" dirty="0" err="1" smtClean="0"/>
-              <a:t>bot</a:t>
-            </a:r>
-            <a:r>
-              <a:rPr lang="en-US" b="1" dirty="0" smtClean="0"/>
-              <a:t>-@</a:t>
-            </a:r>
-            <a:r>
-              <a:rPr lang="en-US" b="1" dirty="0" err="1" smtClean="0"/>
-              <a:t>frimoussethecat</a:t>
-            </a:r>
-            <a:r>
-              <a:rPr lang="en-US" b="1" dirty="0" smtClean="0"/>
-              <a:t>-post-</a:t>
-            </a:r>
-            <a:r>
-              <a:rPr lang="en-US" b="1" dirty="0" err="1" smtClean="0"/>
-              <a:t>shorts.py</a:t>
+              <a:t>social-bot-@frimoussethecat-post-shorts.py</a:t>
             </a:r>
             <a:endParaRPr lang="en-US" b="1" dirty="0"/>
           </a:p>
@@ -7840,37 +7796,8 @@
                   <a:schemeClr val="bg1"/>
                 </a:solidFill>
               </a:rPr>
-              <a:t>social-</a:t>
-            </a:r>
-            <a:r>
-              <a:rPr lang="en-US" b="1" dirty="0" err="1" smtClean="0">
-                <a:solidFill>
-                  <a:schemeClr val="bg1"/>
-                </a:solidFill>
-              </a:rPr>
-              <a:t>bot</a:t>
-            </a:r>
-            <a:r>
-              <a:rPr lang="en-US" b="1" dirty="0" smtClean="0">
-                <a:solidFill>
-                  <a:schemeClr val="bg1"/>
-                </a:solidFill>
-              </a:rPr>
-              <a:t>-…-post-</a:t>
-            </a:r>
-            <a:r>
-              <a:rPr lang="en-US" b="1" dirty="0" err="1" smtClean="0">
-                <a:solidFill>
-                  <a:schemeClr val="bg1"/>
-                </a:solidFill>
-              </a:rPr>
-              <a:t>pics.py</a:t>
-            </a:r>
-            <a:endParaRPr lang="en-US" b="1" dirty="0" smtClean="0">
-              <a:solidFill>
-                <a:schemeClr val="bg1"/>
-              </a:solidFill>
-            </a:endParaRPr>
+              <a:t>social-bot-…-post-pics.py</a:t>
+            </a:r>
           </a:p>
         </p:txBody>
       </p:sp>
@@ -7911,7 +7838,7 @@
           <a:p>
             <a:pPr algn="ctr"/>
             <a:r>
-              <a:rPr lang="en-US" b="1" dirty="0" err="1" smtClean="0">
+              <a:rPr lang="en-US" b="1" dirty="0" smtClean="0">
                 <a:solidFill>
                   <a:schemeClr val="bg1"/>
                 </a:solidFill>
@@ -8015,23 +7942,7 @@
                   <a:schemeClr val="tx1"/>
                 </a:solidFill>
               </a:rPr>
-              <a:t>/ platform/*.</a:t>
-            </a:r>
-            <a:r>
-              <a:rPr lang="en-US" b="1" dirty="0" err="1" smtClean="0">
-                <a:solidFill>
-                  <a:schemeClr val="tx1"/>
-                </a:solidFill>
-              </a:rPr>
-              <a:t>sikuli</a:t>
-            </a:r>
-            <a:r>
-              <a:rPr lang="en-US" b="1" dirty="0" smtClean="0">
-                <a:solidFill>
-                  <a:schemeClr val="tx1"/>
-                </a:solidFill>
-              </a:rPr>
-              <a:t>/*</a:t>
+              <a:t>/ platform/*.sikuli/*</a:t>
             </a:r>
             <a:endParaRPr lang="en-US" b="1" dirty="0">
               <a:solidFill>
@@ -8130,28 +8041,12 @@
           <a:p>
             <a:pPr algn="ctr"/>
             <a:r>
-              <a:rPr lang="en-US" sz="1600" b="1" dirty="0" err="1" smtClean="0">
-                <a:solidFill>
-                  <a:schemeClr val="bg1"/>
-                </a:solidFill>
-              </a:rPr>
-              <a:t>tw</a:t>
-            </a:r>
-            <a:r>
               <a:rPr lang="en-US" sz="1600" b="1" dirty="0" smtClean="0">
                 <a:solidFill>
                   <a:schemeClr val="bg1"/>
                 </a:solidFill>
               </a:rPr>
-              <a:t>-post-</a:t>
-            </a:r>
-            <a:r>
-              <a:rPr lang="en-US" sz="1600" b="1" dirty="0" err="1" smtClean="0">
-                <a:solidFill>
-                  <a:schemeClr val="bg1"/>
-                </a:solidFill>
-              </a:rPr>
-              <a:t>pic</a:t>
+              <a:t>tw-post-pic</a:t>
             </a:r>
             <a:endParaRPr lang="en-US" sz="1600" b="1" dirty="0">
               <a:solidFill>
@@ -8203,37 +8098,8 @@
                   <a:schemeClr val="bg1"/>
                 </a:solidFill>
               </a:rPr>
-              <a:t>social-</a:t>
-            </a:r>
-            <a:r>
-              <a:rPr lang="en-US" b="1" dirty="0" err="1" smtClean="0">
-                <a:solidFill>
-                  <a:schemeClr val="bg1"/>
-                </a:solidFill>
-              </a:rPr>
-              <a:t>bot</a:t>
-            </a:r>
-            <a:r>
-              <a:rPr lang="en-US" b="1" dirty="0" smtClean="0">
-                <a:solidFill>
-                  <a:schemeClr val="bg1"/>
-                </a:solidFill>
-              </a:rPr>
-              <a:t>-…-post-</a:t>
-            </a:r>
-            <a:r>
-              <a:rPr lang="en-US" b="1" dirty="0" err="1" smtClean="0">
-                <a:solidFill>
-                  <a:schemeClr val="bg1"/>
-                </a:solidFill>
-              </a:rPr>
-              <a:t>vids.py</a:t>
-            </a:r>
-            <a:endParaRPr lang="en-US" b="1" dirty="0" smtClean="0">
-              <a:solidFill>
-                <a:schemeClr val="bg1"/>
-              </a:solidFill>
-            </a:endParaRPr>
+              <a:t>social-bot-…-post-vids.py</a:t>
+            </a:r>
           </a:p>
         </p:txBody>
       </p:sp>
@@ -8279,37 +8145,8 @@
                   <a:schemeClr val="bg1"/>
                 </a:solidFill>
               </a:rPr>
-              <a:t>social-</a:t>
-            </a:r>
-            <a:r>
-              <a:rPr lang="en-US" b="1" dirty="0" err="1" smtClean="0">
-                <a:solidFill>
-                  <a:schemeClr val="bg1"/>
-                </a:solidFill>
-              </a:rPr>
-              <a:t>bot</a:t>
-            </a:r>
-            <a:r>
-              <a:rPr lang="en-US" b="1" dirty="0" smtClean="0">
-                <a:solidFill>
-                  <a:schemeClr val="bg1"/>
-                </a:solidFill>
-              </a:rPr>
-              <a:t>-…-post-</a:t>
-            </a:r>
-            <a:r>
-              <a:rPr lang="en-US" b="1" dirty="0" err="1" smtClean="0">
-                <a:solidFill>
-                  <a:schemeClr val="bg1"/>
-                </a:solidFill>
-              </a:rPr>
-              <a:t>shorts.py</a:t>
-            </a:r>
-            <a:endParaRPr lang="en-US" b="1" dirty="0" smtClean="0">
-              <a:solidFill>
-                <a:schemeClr val="bg1"/>
-              </a:solidFill>
-            </a:endParaRPr>
+              <a:t>social-bot-…-post-shorts.py</a:t>
+            </a:r>
           </a:p>
         </p:txBody>
       </p:sp>
@@ -8402,28 +8239,12 @@
           <a:p>
             <a:pPr algn="ctr"/>
             <a:r>
-              <a:rPr lang="en-US" sz="1600" b="1" dirty="0" err="1" smtClean="0">
-                <a:solidFill>
-                  <a:schemeClr val="bg1"/>
-                </a:solidFill>
-              </a:rPr>
-              <a:t>fb</a:t>
-            </a:r>
-            <a:r>
               <a:rPr lang="en-US" sz="1600" b="1" dirty="0" smtClean="0">
                 <a:solidFill>
                   <a:schemeClr val="bg1"/>
                 </a:solidFill>
               </a:rPr>
-              <a:t>-post-</a:t>
-            </a:r>
-            <a:r>
-              <a:rPr lang="en-US" sz="1600" b="1" dirty="0" err="1" smtClean="0">
-                <a:solidFill>
-                  <a:schemeClr val="bg1"/>
-                </a:solidFill>
-              </a:rPr>
-              <a:t>vid</a:t>
+              <a:t>fb-post-vid</a:t>
             </a:r>
             <a:endParaRPr lang="en-US" sz="1600" b="1" dirty="0">
               <a:solidFill>
@@ -8522,28 +8343,12 @@
           <a:p>
             <a:pPr algn="ctr"/>
             <a:r>
-              <a:rPr lang="en-US" sz="1600" b="1" dirty="0" err="1" smtClean="0">
-                <a:solidFill>
-                  <a:schemeClr val="bg1"/>
-                </a:solidFill>
-              </a:rPr>
-              <a:t>fb</a:t>
-            </a:r>
-            <a:r>
               <a:rPr lang="en-US" sz="1600" b="1" dirty="0" smtClean="0">
                 <a:solidFill>
                   <a:schemeClr val="bg1"/>
                 </a:solidFill>
               </a:rPr>
-              <a:t>-post-</a:t>
-            </a:r>
-            <a:r>
-              <a:rPr lang="en-US" sz="1600" b="1" dirty="0" err="1" smtClean="0">
-                <a:solidFill>
-                  <a:schemeClr val="bg1"/>
-                </a:solidFill>
-              </a:rPr>
-              <a:t>pic</a:t>
+              <a:t>fb-post-pic</a:t>
             </a:r>
             <a:endParaRPr lang="en-US" sz="1600" b="1" dirty="0">
               <a:solidFill>
@@ -8590,28 +8395,12 @@
           <a:p>
             <a:pPr algn="ctr"/>
             <a:r>
-              <a:rPr lang="en-US" sz="1600" b="1" dirty="0" err="1" smtClean="0">
-                <a:solidFill>
-                  <a:schemeClr val="bg1"/>
-                </a:solidFill>
-              </a:rPr>
-              <a:t>tw</a:t>
-            </a:r>
-            <a:r>
               <a:rPr lang="en-US" sz="1600" b="1" dirty="0" smtClean="0">
                 <a:solidFill>
                   <a:schemeClr val="bg1"/>
                 </a:solidFill>
               </a:rPr>
-              <a:t>-post-</a:t>
-            </a:r>
-            <a:r>
-              <a:rPr lang="en-US" sz="1600" b="1" dirty="0" err="1" smtClean="0">
-                <a:solidFill>
-                  <a:schemeClr val="bg1"/>
-                </a:solidFill>
-              </a:rPr>
-              <a:t>vid</a:t>
+              <a:t>tw-post-vid</a:t>
             </a:r>
             <a:endParaRPr lang="en-US" sz="1600" b="1" dirty="0">
               <a:solidFill>
@@ -8658,28 +8447,12 @@
           <a:p>
             <a:pPr algn="ctr"/>
             <a:r>
-              <a:rPr lang="en-US" sz="1600" b="1" dirty="0" err="1" smtClean="0">
-                <a:solidFill>
-                  <a:schemeClr val="bg1"/>
-                </a:solidFill>
-              </a:rPr>
-              <a:t>insta</a:t>
-            </a:r>
-            <a:r>
               <a:rPr lang="en-US" sz="1600" b="1" dirty="0" smtClean="0">
                 <a:solidFill>
                   <a:schemeClr val="bg1"/>
                 </a:solidFill>
               </a:rPr>
-              <a:t>-post-</a:t>
-            </a:r>
-            <a:r>
-              <a:rPr lang="en-US" sz="1600" b="1" dirty="0" err="1" smtClean="0">
-                <a:solidFill>
-                  <a:schemeClr val="bg1"/>
-                </a:solidFill>
-              </a:rPr>
-              <a:t>pic</a:t>
+              <a:t>insta-post-pic</a:t>
             </a:r>
             <a:endParaRPr lang="en-US" sz="1600" b="1" dirty="0">
               <a:solidFill>
@@ -8835,7 +8608,7 @@
           <a:lstStyle/>
           <a:p>
             <a:pPr algn="ctr"/>
-            <a:endParaRPr lang="en-US" b="1">
+            <a:endParaRPr lang="en-US" b="1" dirty="0">
               <a:solidFill>
                 <a:schemeClr val="bg1"/>
               </a:solidFill>
@@ -8885,7 +8658,7 @@
           <a:lstStyle/>
           <a:p>
             <a:pPr algn="ctr"/>
-            <a:endParaRPr lang="en-US" b="1">
+            <a:endParaRPr lang="en-US" b="1" dirty="0">
               <a:solidFill>
                 <a:schemeClr val="bg1"/>
               </a:solidFill>
@@ -8935,7 +8708,7 @@
           <a:lstStyle/>
           <a:p>
             <a:pPr algn="ctr"/>
-            <a:endParaRPr lang="en-US" b="1">
+            <a:endParaRPr lang="en-US" b="1" dirty="0">
               <a:solidFill>
                 <a:schemeClr val="bg1"/>
               </a:solidFill>
@@ -9102,7 +8875,7 @@
     </p:spTree>
     <p:extLst>
       <p:ext uri="{BB962C8B-B14F-4D97-AF65-F5344CB8AC3E}">
-        <p14:creationId xmlns:p14="http://schemas.microsoft.com/office/powerpoint/2010/main" xmlns="" val="521620976"/>
+        <p14:creationId xmlns:p14="http://schemas.microsoft.com/office/powerpoint/2010/main" val="521620976"/>
       </p:ext>
     </p:extLst>
   </p:cSld>

</xml_diff>